<commit_message>
Prepare for Render deployment: Add Dockerfile and README
</commit_message>
<xml_diff>
--- a/output/empty_template.pptx
+++ b/output/empty_template.pptx
@@ -13,7 +13,6 @@
     <p:sldId id="261" r:id="rId12"/>
     <p:sldId id="262" r:id="rId13"/>
     <p:sldId id="263" r:id="rId14"/>
-    <p:sldId id="264" r:id="rId15"/>
   </p:sldIdLst>
   <p:sldSz cx="9144000" cy="6858000" type="screen4x3"/>
   <p:notesSz cx="6858000" cy="9144000"/>
@@ -3120,17 +3119,17 @@
           </a:ln>
         </p:spPr>
         <p:txBody>
-          <a:bodyPr wrap="none">
-            <a:spAutoFit/>
+          <a:bodyPr wrap="square">
+            <a:normAutofit/>
           </a:bodyPr>
           <a:lstStyle/>
           <a:p>
             <a:pPr algn="ctr">
-              <a:defRPr sz="4800">
+              <a:defRPr sz="5200">
                 <a:solidFill>
-                  <a:srgbClr val="F9FAFB"/>
+                  <a:srgbClr val="F5F3FF"/>
                 </a:solidFill>
-                <a:latin typeface="Playfair Display"/>
+                <a:latin typeface="Archivo Black"/>
               </a:defRPr>
             </a:pPr>
             <a:r>
@@ -3163,17 +3162,17 @@
           </a:ln>
         </p:spPr>
         <p:txBody>
-          <a:bodyPr wrap="none">
-            <a:spAutoFit/>
+          <a:bodyPr wrap="square">
+            <a:normAutofit/>
           </a:bodyPr>
           <a:lstStyle/>
           <a:p>
             <a:pPr algn="ctr">
-              <a:defRPr sz="1500">
+              <a:defRPr sz="1400">
                 <a:solidFill>
-                  <a:srgbClr val="F9FAFB"/>
+                  <a:srgbClr val="F5F3FF"/>
                 </a:solidFill>
-                <a:latin typeface="Lato"/>
+                <a:latin typeface="Work Sans"/>
               </a:defRPr>
             </a:pPr>
             <a:r>
@@ -3224,17 +3223,17 @@
           </a:ln>
         </p:spPr>
         <p:txBody>
-          <a:bodyPr wrap="none">
-            <a:spAutoFit/>
+          <a:bodyPr wrap="square">
+            <a:normAutofit/>
           </a:bodyPr>
           <a:lstStyle/>
           <a:p>
             <a:pPr algn="l">
-              <a:defRPr sz="4800">
+              <a:defRPr sz="5200">
                 <a:solidFill>
-                  <a:srgbClr val="F9FAFB"/>
+                  <a:srgbClr val="F5F3FF"/>
                 </a:solidFill>
-                <a:latin typeface="Playfair Display"/>
+                <a:latin typeface="Archivo Black"/>
               </a:defRPr>
             </a:pPr>
             <a:r>
@@ -3267,17 +3266,17 @@
           </a:ln>
         </p:spPr>
         <p:txBody>
-          <a:bodyPr wrap="none">
-            <a:spAutoFit/>
+          <a:bodyPr wrap="square">
+            <a:normAutofit/>
           </a:bodyPr>
           <a:lstStyle/>
           <a:p>
             <a:pPr algn="l">
-              <a:defRPr sz="1500">
+              <a:defRPr sz="1400">
                 <a:solidFill>
-                  <a:srgbClr val="F9FAFB"/>
+                  <a:srgbClr val="F5F3FF"/>
                 </a:solidFill>
-                <a:latin typeface="Lato"/>
+                <a:latin typeface="Work Sans"/>
               </a:defRPr>
             </a:pPr>
             <a:r>
@@ -3328,17 +3327,17 @@
           </a:ln>
         </p:spPr>
         <p:txBody>
-          <a:bodyPr wrap="none">
-            <a:spAutoFit/>
+          <a:bodyPr wrap="square">
+            <a:normAutofit/>
           </a:bodyPr>
           <a:lstStyle/>
           <a:p>
             <a:pPr algn="l">
-              <a:defRPr sz="4800">
+              <a:defRPr sz="5200">
                 <a:solidFill>
-                  <a:srgbClr val="F9FAFB"/>
+                  <a:srgbClr val="F5F3FF"/>
                 </a:solidFill>
-                <a:latin typeface="Playfair Display"/>
+                <a:latin typeface="Archivo Black"/>
               </a:defRPr>
             </a:pPr>
             <a:r>
@@ -3362,7 +3361,7 @@
             <a:avLst/>
           </a:prstGeom>
           <a:solidFill>
-            <a:srgbClr val="1F2937"/>
+            <a:srgbClr val="4C1D95"/>
           </a:solidFill>
           <a:ln>
             <a:noFill/>
@@ -3405,7 +3404,7 @@
             <a:avLst/>
           </a:prstGeom>
           <a:solidFill>
-            <a:srgbClr val="1F2937"/>
+            <a:srgbClr val="4C1D95"/>
           </a:solidFill>
           <a:ln>
             <a:noFill/>
@@ -3457,17 +3456,17 @@
           </a:ln>
         </p:spPr>
         <p:txBody>
-          <a:bodyPr wrap="none">
-            <a:spAutoFit/>
+          <a:bodyPr wrap="square">
+            <a:normAutofit/>
           </a:bodyPr>
           <a:lstStyle/>
           <a:p>
             <a:pPr algn="l">
-              <a:defRPr sz="1500">
+              <a:defRPr sz="1400">
                 <a:solidFill>
-                  <a:srgbClr val="F9FAFB"/>
+                  <a:srgbClr val="F5F3FF"/>
                 </a:solidFill>
-                <a:latin typeface="Lato"/>
+                <a:latin typeface="Work Sans"/>
               </a:defRPr>
             </a:pPr>
             <a:r>
@@ -3500,17 +3499,17 @@
           </a:ln>
         </p:spPr>
         <p:txBody>
-          <a:bodyPr wrap="none">
-            <a:spAutoFit/>
+          <a:bodyPr wrap="square">
+            <a:normAutofit/>
           </a:bodyPr>
           <a:lstStyle/>
           <a:p>
             <a:pPr algn="l">
-              <a:defRPr sz="1500">
+              <a:defRPr sz="1400">
                 <a:solidFill>
-                  <a:srgbClr val="F9FAFB"/>
+                  <a:srgbClr val="F5F3FF"/>
                 </a:solidFill>
-                <a:latin typeface="Lato"/>
+                <a:latin typeface="Work Sans"/>
               </a:defRPr>
             </a:pPr>
             <a:r>
@@ -3545,8 +3544,8 @@
         </p:nvSpPr>
         <p:spPr>
           <a:xfrm>
-            <a:off x="3657600" y="457200"/>
-            <a:ext cx="5029200" cy="5943600"/>
+            <a:off x="457200" y="1371600"/>
+            <a:ext cx="2286000" cy="3657600"/>
           </a:xfrm>
           <a:prstGeom prst="rect">
             <a:avLst/>
@@ -3561,21 +3560,21 @@
           </a:ln>
         </p:spPr>
         <p:txBody>
-          <a:bodyPr wrap="none">
-            <a:spAutoFit/>
+          <a:bodyPr wrap="square">
+            <a:normAutofit/>
           </a:bodyPr>
           <a:lstStyle/>
           <a:p>
             <a:pPr algn="l">
-              <a:defRPr sz="1500">
+              <a:defRPr sz="5200">
                 <a:solidFill>
-                  <a:srgbClr val="F9FAFB"/>
+                  <a:srgbClr val="F5F3FF"/>
                 </a:solidFill>
-                <a:latin typeface="Lato"/>
+                <a:latin typeface="Archivo Black"/>
               </a:defRPr>
             </a:pPr>
             <a:r>
-              <a:t>[visual]</a:t>
+              <a:t>[title]</a:t>
             </a:r>
           </a:p>
         </p:txBody>
@@ -3588,8 +3587,8 @@
         </p:nvSpPr>
         <p:spPr>
           <a:xfrm>
-            <a:off x="457200" y="457200"/>
-            <a:ext cx="2743200" cy="5943600"/>
+            <a:off x="3200400" y="1371600"/>
+            <a:ext cx="5486400" cy="4572000"/>
           </a:xfrm>
           <a:prstGeom prst="rect">
             <a:avLst/>
@@ -3604,21 +3603,21 @@
           </a:ln>
         </p:spPr>
         <p:txBody>
-          <a:bodyPr wrap="none">
-            <a:spAutoFit/>
+          <a:bodyPr wrap="square">
+            <a:normAutofit/>
           </a:bodyPr>
           <a:lstStyle/>
           <a:p>
             <a:pPr algn="l">
-              <a:defRPr sz="1500">
+              <a:defRPr sz="1400">
                 <a:solidFill>
-                  <a:srgbClr val="F9FAFB"/>
+                  <a:srgbClr val="F5F3FF"/>
                 </a:solidFill>
-                <a:latin typeface="Lato"/>
+                <a:latin typeface="Work Sans"/>
               </a:defRPr>
             </a:pPr>
             <a:r>
-              <a:t>[text_group]</a:t>
+              <a:t>[bullets]</a:t>
             </a:r>
           </a:p>
         </p:txBody>
@@ -3643,100 +3642,14 @@
       <p:grpSpPr/>
       <p:sp>
         <p:nvSpPr>
-          <p:cNvPr id="2" name="Rectangle 1"/>
-          <p:cNvSpPr/>
+          <p:cNvPr id="2" name="TextBox 1"/>
+          <p:cNvSpPr txBox="1"/>
           <p:nvPr/>
         </p:nvSpPr>
         <p:spPr>
           <a:xfrm>
-            <a:off x="0" y="0"/>
-            <a:ext cx="4572000" cy="6858000"/>
-          </a:xfrm>
-          <a:prstGeom prst="rect">
-            <a:avLst/>
-          </a:prstGeom>
-          <a:solidFill>
-            <a:srgbClr val="1F2937"/>
-          </a:solidFill>
-          <a:ln>
-            <a:noFill/>
-          </a:ln>
-        </p:spPr>
-        <p:style>
-          <a:lnRef idx="1">
-            <a:schemeClr val="accent1"/>
-          </a:lnRef>
-          <a:fillRef idx="3">
-            <a:schemeClr val="accent1"/>
-          </a:fillRef>
-          <a:effectRef idx="2">
-            <a:schemeClr val="accent1"/>
-          </a:effectRef>
-          <a:fontRef idx="minor">
-            <a:schemeClr val="lt1"/>
-          </a:fontRef>
-        </p:style>
-        <p:txBody>
-          <a:bodyPr rtlCol="0" anchor="ctr"/>
-          <a:lstStyle/>
-          <a:p>
-            <a:pPr algn="ctr"/>
-          </a:p>
-        </p:txBody>
-      </p:sp>
-      <p:sp>
-        <p:nvSpPr>
-          <p:cNvPr id="3" name="Rectangle 2"/>
-          <p:cNvSpPr/>
-          <p:nvPr/>
-        </p:nvSpPr>
-        <p:spPr>
-          <a:xfrm>
-            <a:off x="4572000" y="0"/>
-            <a:ext cx="4572000" cy="6858000"/>
-          </a:xfrm>
-          <a:prstGeom prst="rect">
-            <a:avLst/>
-          </a:prstGeom>
-          <a:solidFill>
-            <a:srgbClr val="1F2937"/>
-          </a:solidFill>
-          <a:ln>
-            <a:noFill/>
-          </a:ln>
-        </p:spPr>
-        <p:style>
-          <a:lnRef idx="1">
-            <a:schemeClr val="accent1"/>
-          </a:lnRef>
-          <a:fillRef idx="3">
-            <a:schemeClr val="accent1"/>
-          </a:fillRef>
-          <a:effectRef idx="2">
-            <a:schemeClr val="accent1"/>
-          </a:effectRef>
-          <a:fontRef idx="minor">
-            <a:schemeClr val="lt1"/>
-          </a:fontRef>
-        </p:style>
-        <p:txBody>
-          <a:bodyPr rtlCol="0" anchor="ctr"/>
-          <a:lstStyle/>
-          <a:p>
-            <a:pPr algn="ctr"/>
-          </a:p>
-        </p:txBody>
-      </p:sp>
-      <p:sp>
-        <p:nvSpPr>
-          <p:cNvPr id="4" name="TextBox 3"/>
-          <p:cNvSpPr txBox="1"/>
-          <p:nvPr/>
-        </p:nvSpPr>
-        <p:spPr>
-          <a:xfrm>
-            <a:off x="457200" y="2011680"/>
-            <a:ext cx="3657600" cy="914400"/>
+            <a:off x="3657600" y="457200"/>
+            <a:ext cx="5029200" cy="5943600"/>
           </a:xfrm>
           <a:prstGeom prst="rect">
             <a:avLst/>
@@ -3751,35 +3664,35 @@
           </a:ln>
         </p:spPr>
         <p:txBody>
-          <a:bodyPr wrap="none">
-            <a:spAutoFit/>
+          <a:bodyPr wrap="square">
+            <a:normAutofit/>
           </a:bodyPr>
           <a:lstStyle/>
           <a:p>
-            <a:pPr algn="ctr">
-              <a:defRPr sz="1500">
+            <a:pPr algn="l">
+              <a:defRPr sz="1400">
                 <a:solidFill>
-                  <a:srgbClr val="F9FAFB"/>
+                  <a:srgbClr val="F5F3FF"/>
                 </a:solidFill>
-                <a:latin typeface="Lato"/>
+                <a:latin typeface="Work Sans"/>
               </a:defRPr>
             </a:pPr>
             <a:r>
-              <a:t>[title_left]</a:t>
-            </a:r>
-          </a:p>
-        </p:txBody>
-      </p:sp>
-      <p:sp>
-        <p:nvSpPr>
-          <p:cNvPr id="5" name="TextBox 4"/>
+              <a:t>[visual]</a:t>
+            </a:r>
+          </a:p>
+        </p:txBody>
+      </p:sp>
+      <p:sp>
+        <p:nvSpPr>
+          <p:cNvPr id="3" name="TextBox 2"/>
           <p:cNvSpPr txBox="1"/>
           <p:nvPr/>
         </p:nvSpPr>
         <p:spPr>
           <a:xfrm>
-            <a:off x="457200" y="3108960"/>
-            <a:ext cx="3657600" cy="2743200"/>
+            <a:off x="457200" y="457200"/>
+            <a:ext cx="2743200" cy="5943600"/>
           </a:xfrm>
           <a:prstGeom prst="rect">
             <a:avLst/>
@@ -3794,107 +3707,21 @@
           </a:ln>
         </p:spPr>
         <p:txBody>
-          <a:bodyPr wrap="none">
-            <a:spAutoFit/>
+          <a:bodyPr wrap="square">
+            <a:normAutofit/>
           </a:bodyPr>
           <a:lstStyle/>
           <a:p>
-            <a:pPr algn="ctr">
-              <a:defRPr sz="1500">
+            <a:pPr algn="l">
+              <a:defRPr sz="1400">
                 <a:solidFill>
-                  <a:srgbClr val="F9FAFB"/>
+                  <a:srgbClr val="F5F3FF"/>
                 </a:solidFill>
-                <a:latin typeface="Lato"/>
+                <a:latin typeface="Work Sans"/>
               </a:defRPr>
             </a:pPr>
             <a:r>
-              <a:t>[body_left]</a:t>
-            </a:r>
-          </a:p>
-        </p:txBody>
-      </p:sp>
-      <p:sp>
-        <p:nvSpPr>
-          <p:cNvPr id="6" name="TextBox 5"/>
-          <p:cNvSpPr txBox="1"/>
-          <p:nvPr/>
-        </p:nvSpPr>
-        <p:spPr>
-          <a:xfrm>
-            <a:off x="5029200" y="2011680"/>
-            <a:ext cx="3657600" cy="914400"/>
-          </a:xfrm>
-          <a:prstGeom prst="rect">
-            <a:avLst/>
-          </a:prstGeom>
-          <a:solidFill>
-            <a:srgbClr val="F5F5F5"/>
-          </a:solidFill>
-          <a:ln w="9525">
-            <a:solidFill>
-              <a:srgbClr val="C8C8C8"/>
-            </a:solidFill>
-          </a:ln>
-        </p:spPr>
-        <p:txBody>
-          <a:bodyPr wrap="none">
-            <a:spAutoFit/>
-          </a:bodyPr>
-          <a:lstStyle/>
-          <a:p>
-            <a:pPr algn="ctr">
-              <a:defRPr sz="1500">
-                <a:solidFill>
-                  <a:srgbClr val="F9FAFB"/>
-                </a:solidFill>
-                <a:latin typeface="Lato"/>
-              </a:defRPr>
-            </a:pPr>
-            <a:r>
-              <a:t>[title_right]</a:t>
-            </a:r>
-          </a:p>
-        </p:txBody>
-      </p:sp>
-      <p:sp>
-        <p:nvSpPr>
-          <p:cNvPr id="7" name="TextBox 6"/>
-          <p:cNvSpPr txBox="1"/>
-          <p:nvPr/>
-        </p:nvSpPr>
-        <p:spPr>
-          <a:xfrm>
-            <a:off x="5029200" y="3108960"/>
-            <a:ext cx="3657600" cy="2743200"/>
-          </a:xfrm>
-          <a:prstGeom prst="rect">
-            <a:avLst/>
-          </a:prstGeom>
-          <a:solidFill>
-            <a:srgbClr val="F5F5F5"/>
-          </a:solidFill>
-          <a:ln w="9525">
-            <a:solidFill>
-              <a:srgbClr val="C8C8C8"/>
-            </a:solidFill>
-          </a:ln>
-        </p:spPr>
-        <p:txBody>
-          <a:bodyPr wrap="none">
-            <a:spAutoFit/>
-          </a:bodyPr>
-          <a:lstStyle/>
-          <a:p>
-            <a:pPr algn="ctr">
-              <a:defRPr sz="1500">
-                <a:solidFill>
-                  <a:srgbClr val="F9FAFB"/>
-                </a:solidFill>
-                <a:latin typeface="Lato"/>
-              </a:defRPr>
-            </a:pPr>
-            <a:r>
-              <a:t>[body_right]</a:t>
+              <a:t>[text_group]</a:t>
             </a:r>
           </a:p>
         </p:txBody>
@@ -3925,8 +3752,8 @@
         </p:nvSpPr>
         <p:spPr>
           <a:xfrm>
-            <a:off x="457200" y="1371600"/>
-            <a:ext cx="3657600" cy="2743200"/>
+            <a:off x="1371600" y="2286000"/>
+            <a:ext cx="2743200" cy="2743200"/>
           </a:xfrm>
           <a:prstGeom prst="rect">
             <a:avLst/>
@@ -3941,21 +3768,21 @@
           </a:ln>
         </p:spPr>
         <p:txBody>
-          <a:bodyPr wrap="none">
-            <a:spAutoFit/>
+          <a:bodyPr wrap="square">
+            <a:normAutofit/>
           </a:bodyPr>
           <a:lstStyle/>
           <a:p>
             <a:pPr algn="l">
-              <a:defRPr sz="1500">
+              <a:defRPr sz="1400">
                 <a:solidFill>
-                  <a:srgbClr val="F9FAFB"/>
+                  <a:srgbClr val="F5F3FF"/>
                 </a:solidFill>
-                <a:latin typeface="Lato"/>
+                <a:latin typeface="Work Sans"/>
               </a:defRPr>
             </a:pPr>
             <a:r>
-              <a:t>[col_top]</a:t>
+              <a:t>[box1]</a:t>
             </a:r>
           </a:p>
         </p:txBody>
@@ -3968,8 +3795,8 @@
         </p:nvSpPr>
         <p:spPr>
           <a:xfrm>
-            <a:off x="5029200" y="3200400"/>
-            <a:ext cx="3657600" cy="2743200"/>
+            <a:off x="5029200" y="2286000"/>
+            <a:ext cx="2743200" cy="2743200"/>
           </a:xfrm>
           <a:prstGeom prst="rect">
             <a:avLst/>
@@ -3984,21 +3811,21 @@
           </a:ln>
         </p:spPr>
         <p:txBody>
-          <a:bodyPr wrap="none">
-            <a:spAutoFit/>
+          <a:bodyPr wrap="square">
+            <a:normAutofit/>
           </a:bodyPr>
           <a:lstStyle/>
           <a:p>
             <a:pPr algn="l">
-              <a:defRPr sz="1500">
+              <a:defRPr sz="1400">
                 <a:solidFill>
-                  <a:srgbClr val="F9FAFB"/>
+                  <a:srgbClr val="F5F3FF"/>
                 </a:solidFill>
-                <a:latin typeface="Lato"/>
+                <a:latin typeface="Work Sans"/>
               </a:defRPr>
             </a:pPr>
             <a:r>
-              <a:t>[col_bottom]</a:t>
+              <a:t>[box2]</a:t>
             </a:r>
           </a:p>
         </p:txBody>
@@ -4023,57 +3850,14 @@
       <p:grpSpPr/>
       <p:sp>
         <p:nvSpPr>
-          <p:cNvPr id="2" name="Rectangle 1"/>
-          <p:cNvSpPr/>
+          <p:cNvPr id="2" name="TextBox 1"/>
+          <p:cNvSpPr txBox="1"/>
           <p:nvPr/>
         </p:nvSpPr>
         <p:spPr>
           <a:xfrm>
-            <a:off x="0" y="457200"/>
-            <a:ext cx="9144000" cy="1097280"/>
-          </a:xfrm>
-          <a:prstGeom prst="rect">
-            <a:avLst/>
-          </a:prstGeom>
-          <a:solidFill>
-            <a:srgbClr val="1F2937"/>
-          </a:solidFill>
-          <a:ln>
-            <a:noFill/>
-          </a:ln>
-        </p:spPr>
-        <p:style>
-          <a:lnRef idx="1">
-            <a:schemeClr val="accent1"/>
-          </a:lnRef>
-          <a:fillRef idx="3">
-            <a:schemeClr val="accent1"/>
-          </a:fillRef>
-          <a:effectRef idx="2">
-            <a:schemeClr val="accent1"/>
-          </a:effectRef>
-          <a:fontRef idx="minor">
-            <a:schemeClr val="lt1"/>
-          </a:fontRef>
-        </p:style>
-        <p:txBody>
-          <a:bodyPr rtlCol="0" anchor="ctr"/>
-          <a:lstStyle/>
-          <a:p>
-            <a:pPr algn="ctr"/>
-          </a:p>
-        </p:txBody>
-      </p:sp>
-      <p:sp>
-        <p:nvSpPr>
-          <p:cNvPr id="3" name="TextBox 2"/>
-          <p:cNvSpPr txBox="1"/>
-          <p:nvPr/>
-        </p:nvSpPr>
-        <p:spPr>
-          <a:xfrm>
-            <a:off x="457200" y="548640"/>
-            <a:ext cx="8229600" cy="914400"/>
+            <a:off x="457200" y="2743200"/>
+            <a:ext cx="8229600" cy="1371600"/>
           </a:xfrm>
           <a:prstGeom prst="rect">
             <a:avLst/>
@@ -4088,64 +3872,21 @@
           </a:ln>
         </p:spPr>
         <p:txBody>
-          <a:bodyPr wrap="none">
-            <a:spAutoFit/>
+          <a:bodyPr wrap="square">
+            <a:normAutofit/>
           </a:bodyPr>
           <a:lstStyle/>
           <a:p>
             <a:pPr algn="l">
-              <a:defRPr sz="4800">
+              <a:defRPr sz="5200">
                 <a:solidFill>
-                  <a:srgbClr val="F9FAFB"/>
+                  <a:srgbClr val="F5F3FF"/>
                 </a:solidFill>
-                <a:latin typeface="Playfair Display"/>
+                <a:latin typeface="Archivo Black"/>
               </a:defRPr>
             </a:pPr>
             <a:r>
               <a:t>[title]</a:t>
-            </a:r>
-          </a:p>
-        </p:txBody>
-      </p:sp>
-      <p:sp>
-        <p:nvSpPr>
-          <p:cNvPr id="4" name="TextBox 3"/>
-          <p:cNvSpPr txBox="1"/>
-          <p:nvPr/>
-        </p:nvSpPr>
-        <p:spPr>
-          <a:xfrm>
-            <a:off x="914400" y="2011680"/>
-            <a:ext cx="7315200" cy="4114800"/>
-          </a:xfrm>
-          <a:prstGeom prst="rect">
-            <a:avLst/>
-          </a:prstGeom>
-          <a:solidFill>
-            <a:srgbClr val="F5F5F5"/>
-          </a:solidFill>
-          <a:ln w="9525">
-            <a:solidFill>
-              <a:srgbClr val="C8C8C8"/>
-            </a:solidFill>
-          </a:ln>
-        </p:spPr>
-        <p:txBody>
-          <a:bodyPr wrap="none">
-            <a:spAutoFit/>
-          </a:bodyPr>
-          <a:lstStyle/>
-          <a:p>
-            <a:pPr algn="l">
-              <a:defRPr sz="1500">
-                <a:solidFill>
-                  <a:srgbClr val="F9FAFB"/>
-                </a:solidFill>
-                <a:latin typeface="Lato"/>
-              </a:defRPr>
-            </a:pPr>
-            <a:r>
-              <a:t>[body]</a:t>
             </a:r>
           </a:p>
         </p:txBody>
@@ -4176,325 +3917,6 @@
         </p:nvSpPr>
         <p:spPr>
           <a:xfrm>
-            <a:off x="457200" y="457200"/>
-            <a:ext cx="8229600" cy="731520"/>
-          </a:xfrm>
-          <a:prstGeom prst="rect">
-            <a:avLst/>
-          </a:prstGeom>
-          <a:solidFill>
-            <a:srgbClr val="F5F5F5"/>
-          </a:solidFill>
-          <a:ln w="9525">
-            <a:solidFill>
-              <a:srgbClr val="C8C8C8"/>
-            </a:solidFill>
-          </a:ln>
-        </p:spPr>
-        <p:txBody>
-          <a:bodyPr wrap="none">
-            <a:spAutoFit/>
-          </a:bodyPr>
-          <a:lstStyle/>
-          <a:p>
-            <a:pPr algn="ctr">
-              <a:defRPr sz="1500">
-                <a:solidFill>
-                  <a:srgbClr val="F9FAFB"/>
-                </a:solidFill>
-                <a:latin typeface="Lato"/>
-              </a:defRPr>
-            </a:pPr>
-            <a:r>
-              <a:t>[main_title]</a:t>
-            </a:r>
-          </a:p>
-        </p:txBody>
-      </p:sp>
-      <p:sp>
-        <p:nvSpPr>
-          <p:cNvPr id="3" name="TextBox 2"/>
-          <p:cNvSpPr txBox="1"/>
-          <p:nvPr/>
-        </p:nvSpPr>
-        <p:spPr>
-          <a:xfrm>
-            <a:off x="457200" y="1645920"/>
-            <a:ext cx="2560320" cy="548640"/>
-          </a:xfrm>
-          <a:prstGeom prst="rect">
-            <a:avLst/>
-          </a:prstGeom>
-          <a:solidFill>
-            <a:srgbClr val="F5F5F5"/>
-          </a:solidFill>
-          <a:ln w="9525">
-            <a:solidFill>
-              <a:srgbClr val="C8C8C8"/>
-            </a:solidFill>
-          </a:ln>
-        </p:spPr>
-        <p:txBody>
-          <a:bodyPr wrap="none">
-            <a:spAutoFit/>
-          </a:bodyPr>
-          <a:lstStyle/>
-          <a:p>
-            <a:pPr algn="ctr">
-              <a:defRPr sz="1500">
-                <a:solidFill>
-                  <a:srgbClr val="F9FAFB"/>
-                </a:solidFill>
-                <a:latin typeface="Lato"/>
-              </a:defRPr>
-            </a:pPr>
-            <a:r>
-              <a:t>[title_1]</a:t>
-            </a:r>
-          </a:p>
-        </p:txBody>
-      </p:sp>
-      <p:sp>
-        <p:nvSpPr>
-          <p:cNvPr id="4" name="TextBox 3"/>
-          <p:cNvSpPr txBox="1"/>
-          <p:nvPr/>
-        </p:nvSpPr>
-        <p:spPr>
-          <a:xfrm>
-            <a:off x="457200" y="2377440"/>
-            <a:ext cx="2560320" cy="3657600"/>
-          </a:xfrm>
-          <a:prstGeom prst="rect">
-            <a:avLst/>
-          </a:prstGeom>
-          <a:solidFill>
-            <a:srgbClr val="F5F5F5"/>
-          </a:solidFill>
-          <a:ln w="9525">
-            <a:solidFill>
-              <a:srgbClr val="C8C8C8"/>
-            </a:solidFill>
-          </a:ln>
-        </p:spPr>
-        <p:txBody>
-          <a:bodyPr wrap="none">
-            <a:spAutoFit/>
-          </a:bodyPr>
-          <a:lstStyle/>
-          <a:p>
-            <a:pPr algn="l">
-              <a:defRPr sz="1500">
-                <a:solidFill>
-                  <a:srgbClr val="F9FAFB"/>
-                </a:solidFill>
-                <a:latin typeface="Lato"/>
-              </a:defRPr>
-            </a:pPr>
-            <a:r>
-              <a:t>[body_1]</a:t>
-            </a:r>
-          </a:p>
-        </p:txBody>
-      </p:sp>
-      <p:sp>
-        <p:nvSpPr>
-          <p:cNvPr id="5" name="TextBox 4"/>
-          <p:cNvSpPr txBox="1"/>
-          <p:nvPr/>
-        </p:nvSpPr>
-        <p:spPr>
-          <a:xfrm>
-            <a:off x="3291840" y="1645920"/>
-            <a:ext cx="2560320" cy="548640"/>
-          </a:xfrm>
-          <a:prstGeom prst="rect">
-            <a:avLst/>
-          </a:prstGeom>
-          <a:solidFill>
-            <a:srgbClr val="F5F5F5"/>
-          </a:solidFill>
-          <a:ln w="9525">
-            <a:solidFill>
-              <a:srgbClr val="C8C8C8"/>
-            </a:solidFill>
-          </a:ln>
-        </p:spPr>
-        <p:txBody>
-          <a:bodyPr wrap="none">
-            <a:spAutoFit/>
-          </a:bodyPr>
-          <a:lstStyle/>
-          <a:p>
-            <a:pPr algn="ctr">
-              <a:defRPr sz="1500">
-                <a:solidFill>
-                  <a:srgbClr val="F9FAFB"/>
-                </a:solidFill>
-                <a:latin typeface="Lato"/>
-              </a:defRPr>
-            </a:pPr>
-            <a:r>
-              <a:t>[title_2]</a:t>
-            </a:r>
-          </a:p>
-        </p:txBody>
-      </p:sp>
-      <p:sp>
-        <p:nvSpPr>
-          <p:cNvPr id="6" name="TextBox 5"/>
-          <p:cNvSpPr txBox="1"/>
-          <p:nvPr/>
-        </p:nvSpPr>
-        <p:spPr>
-          <a:xfrm>
-            <a:off x="3291840" y="2377440"/>
-            <a:ext cx="2560320" cy="3657600"/>
-          </a:xfrm>
-          <a:prstGeom prst="rect">
-            <a:avLst/>
-          </a:prstGeom>
-          <a:solidFill>
-            <a:srgbClr val="F5F5F5"/>
-          </a:solidFill>
-          <a:ln w="9525">
-            <a:solidFill>
-              <a:srgbClr val="C8C8C8"/>
-            </a:solidFill>
-          </a:ln>
-        </p:spPr>
-        <p:txBody>
-          <a:bodyPr wrap="none">
-            <a:spAutoFit/>
-          </a:bodyPr>
-          <a:lstStyle/>
-          <a:p>
-            <a:pPr algn="l">
-              <a:defRPr sz="1500">
-                <a:solidFill>
-                  <a:srgbClr val="F9FAFB"/>
-                </a:solidFill>
-                <a:latin typeface="Lato"/>
-              </a:defRPr>
-            </a:pPr>
-            <a:r>
-              <a:t>[body_2]</a:t>
-            </a:r>
-          </a:p>
-        </p:txBody>
-      </p:sp>
-      <p:sp>
-        <p:nvSpPr>
-          <p:cNvPr id="7" name="TextBox 6"/>
-          <p:cNvSpPr txBox="1"/>
-          <p:nvPr/>
-        </p:nvSpPr>
-        <p:spPr>
-          <a:xfrm>
-            <a:off x="6126480" y="1645920"/>
-            <a:ext cx="2560320" cy="548640"/>
-          </a:xfrm>
-          <a:prstGeom prst="rect">
-            <a:avLst/>
-          </a:prstGeom>
-          <a:solidFill>
-            <a:srgbClr val="F5F5F5"/>
-          </a:solidFill>
-          <a:ln w="9525">
-            <a:solidFill>
-              <a:srgbClr val="C8C8C8"/>
-            </a:solidFill>
-          </a:ln>
-        </p:spPr>
-        <p:txBody>
-          <a:bodyPr wrap="none">
-            <a:spAutoFit/>
-          </a:bodyPr>
-          <a:lstStyle/>
-          <a:p>
-            <a:pPr algn="ctr">
-              <a:defRPr sz="1500">
-                <a:solidFill>
-                  <a:srgbClr val="F9FAFB"/>
-                </a:solidFill>
-                <a:latin typeface="Lato"/>
-              </a:defRPr>
-            </a:pPr>
-            <a:r>
-              <a:t>[title_3]</a:t>
-            </a:r>
-          </a:p>
-        </p:txBody>
-      </p:sp>
-      <p:sp>
-        <p:nvSpPr>
-          <p:cNvPr id="8" name="TextBox 7"/>
-          <p:cNvSpPr txBox="1"/>
-          <p:nvPr/>
-        </p:nvSpPr>
-        <p:spPr>
-          <a:xfrm>
-            <a:off x="6126480" y="2377440"/>
-            <a:ext cx="2560320" cy="3657600"/>
-          </a:xfrm>
-          <a:prstGeom prst="rect">
-            <a:avLst/>
-          </a:prstGeom>
-          <a:solidFill>
-            <a:srgbClr val="F5F5F5"/>
-          </a:solidFill>
-          <a:ln w="9525">
-            <a:solidFill>
-              <a:srgbClr val="C8C8C8"/>
-            </a:solidFill>
-          </a:ln>
-        </p:spPr>
-        <p:txBody>
-          <a:bodyPr wrap="none">
-            <a:spAutoFit/>
-          </a:bodyPr>
-          <a:lstStyle/>
-          <a:p>
-            <a:pPr algn="l">
-              <a:defRPr sz="1500">
-                <a:solidFill>
-                  <a:srgbClr val="F9FAFB"/>
-                </a:solidFill>
-                <a:latin typeface="Lato"/>
-              </a:defRPr>
-            </a:pPr>
-            <a:r>
-              <a:t>[body_3]</a:t>
-            </a:r>
-          </a:p>
-        </p:txBody>
-      </p:sp>
-    </p:spTree>
-  </p:cSld>
-  <p:clrMapOvr>
-    <a:masterClrMapping/>
-  </p:clrMapOvr>
-</p:sld>
-</file>
-
-<file path=ppt/slides/slide9.xml><?xml version="1.0" encoding="utf-8"?>
-<p:sld xmlns:a="http://schemas.openxmlformats.org/drawingml/2006/main" xmlns:p="http://schemas.openxmlformats.org/presentationml/2006/main" xmlns:r="http://schemas.openxmlformats.org/officeDocument/2006/relationships">
-  <p:cSld>
-    <p:spTree>
-      <p:nvGrpSpPr>
-        <p:cNvPr id="1" name=""/>
-        <p:cNvGrpSpPr/>
-        <p:nvPr/>
-      </p:nvGrpSpPr>
-      <p:grpSpPr/>
-      <p:sp>
-        <p:nvSpPr>
-          <p:cNvPr id="2" name="TextBox 1"/>
-          <p:cNvSpPr txBox="1"/>
-          <p:nvPr/>
-        </p:nvSpPr>
-        <p:spPr>
-          <a:xfrm>
             <a:off x="1828800" y="731520"/>
             <a:ext cx="5486400" cy="914400"/>
           </a:xfrm>
@@ -4511,17 +3933,17 @@
           </a:ln>
         </p:spPr>
         <p:txBody>
-          <a:bodyPr wrap="none">
-            <a:spAutoFit/>
+          <a:bodyPr wrap="square">
+            <a:normAutofit/>
           </a:bodyPr>
           <a:lstStyle/>
           <a:p>
             <a:pPr algn="l">
-              <a:defRPr sz="4800">
+              <a:defRPr sz="5200">
                 <a:solidFill>
-                  <a:srgbClr val="F9FAFB"/>
+                  <a:srgbClr val="F5F3FF"/>
                 </a:solidFill>
-                <a:latin typeface="Playfair Display"/>
+                <a:latin typeface="Archivo Black"/>
               </a:defRPr>
             </a:pPr>
             <a:r>
@@ -4554,17 +3976,17 @@
           </a:ln>
         </p:spPr>
         <p:txBody>
-          <a:bodyPr wrap="none">
-            <a:spAutoFit/>
+          <a:bodyPr wrap="square">
+            <a:normAutofit/>
           </a:bodyPr>
           <a:lstStyle/>
           <a:p>
             <a:pPr algn="l">
-              <a:defRPr sz="1500">
+              <a:defRPr sz="1400">
                 <a:solidFill>
-                  <a:srgbClr val="F9FAFB"/>
+                  <a:srgbClr val="F5F3FF"/>
                 </a:solidFill>
-                <a:latin typeface="Lato"/>
+                <a:latin typeface="Work Sans"/>
               </a:defRPr>
             </a:pPr>
             <a:r>

</xml_diff>